<commit_message>
Deck v4.1: fix the PowerPoint overlap — real margins, sized-to-fit boxes
Two real bugs found once Ashley opened it in PowerPoint: pptxgenjs margins
are points (0.14 meant zero padding, text jammed at shape edges), and five
fixed-height shapes overflowed at the 14pt floor. Built a text-fit
estimator (Arial metrics, per-paragraph wrap model) into the QA; resized
the title placeholder and back-test tiles until every box fits. All checks
green: font floor, placeholders, bounds, fit.

Co-Authored-By: Claude Fable 5 <noreply@anthropic.com>
</commit_message>
<xml_diff>
--- a/docs/CareerStar-CapitalOne.pptx
+++ b/docs/CareerStar-CapitalOne.pptx
@@ -1897,7 +1897,7 @@
         <p:spPr>
           <a:xfrm>
             <a:off x="548640" y="777240"/>
-            <a:ext cx="11091672" cy="914400"/>
+            <a:ext cx="11091672" cy="1143000"/>
           </a:xfrm>
           <a:prstGeom prst="rect">
             <a:avLst/>
@@ -2480,7 +2480,7 @@
           </a:ln>
         </p:spPr>
         <p:txBody>
-          <a:bodyPr wrap="square" lIns="1270" tIns="1270" rIns="1270" bIns="1270" rtlCol="0" anchor="ctr"/>
+          <a:bodyPr wrap="square" lIns="101600" tIns="101600" rIns="101600" bIns="101600" rtlCol="0" anchor="ctr"/>
           <a:lstStyle/>
           <a:p>
             <a:pPr algn="ctr" indent="0" marL="0">
@@ -2625,7 +2625,7 @@
         <p:spPr>
           <a:xfrm>
             <a:off x="548640" y="777240"/>
-            <a:ext cx="11091672" cy="914400"/>
+            <a:ext cx="11091672" cy="1143000"/>
           </a:xfrm>
           <a:prstGeom prst="rect">
             <a:avLst/>
@@ -2681,7 +2681,7 @@
           </a:ln>
         </p:spPr>
         <p:txBody>
-          <a:bodyPr wrap="square" lIns="1778" tIns="1778" rIns="1778" bIns="1778" rtlCol="0" anchor="t"/>
+          <a:bodyPr wrap="square" lIns="127000" tIns="127000" rIns="127000" bIns="127000" rtlCol="0" anchor="t"/>
           <a:lstStyle/>
           <a:p>
             <a:pPr algn="l" indent="0" marL="0">
@@ -2768,7 +2768,7 @@
           </a:ln>
         </p:spPr>
         <p:txBody>
-          <a:bodyPr wrap="square" lIns="1778" tIns="1778" rIns="1778" bIns="1778" rtlCol="0" anchor="t"/>
+          <a:bodyPr wrap="square" lIns="127000" tIns="127000" rIns="127000" bIns="127000" rtlCol="0" anchor="t"/>
           <a:lstStyle/>
           <a:p>
             <a:pPr algn="l" indent="0" marL="0">
@@ -2838,7 +2838,7 @@
           </a:ln>
         </p:spPr>
         <p:txBody>
-          <a:bodyPr wrap="square" lIns="1778" tIns="1778" rIns="1778" bIns="1778" rtlCol="0" anchor="t"/>
+          <a:bodyPr wrap="square" lIns="127000" tIns="127000" rIns="127000" bIns="127000" rtlCol="0" anchor="t"/>
           <a:lstStyle/>
           <a:p>
             <a:pPr algn="l" indent="0" marL="0">
@@ -2986,7 +2986,7 @@
           </a:ln>
         </p:spPr>
         <p:txBody>
-          <a:bodyPr wrap="square" lIns="1778" tIns="1778" rIns="1778" bIns="1778" rtlCol="0" anchor="ctr"/>
+          <a:bodyPr wrap="square" lIns="127000" tIns="127000" rIns="127000" bIns="127000" rtlCol="0" anchor="ctr"/>
           <a:lstStyle/>
           <a:p>
             <a:pPr algn="l" indent="0" marL="0">
@@ -3122,7 +3122,7 @@
         <p:spPr>
           <a:xfrm>
             <a:off x="548640" y="777240"/>
-            <a:ext cx="11091672" cy="914400"/>
+            <a:ext cx="11091672" cy="1143000"/>
           </a:xfrm>
           <a:prstGeom prst="rect">
             <a:avLst/>
@@ -3178,7 +3178,7 @@
           </a:ln>
         </p:spPr>
         <p:txBody>
-          <a:bodyPr wrap="square" lIns="1778" tIns="1778" rIns="1778" bIns="1778" rtlCol="0" anchor="ctr"/>
+          <a:bodyPr wrap="square" lIns="127000" tIns="127000" rIns="127000" bIns="127000" rtlCol="0" anchor="ctr"/>
           <a:lstStyle/>
           <a:p>
             <a:pPr algn="l" indent="0" marL="0">
@@ -3239,7 +3239,7 @@
           </a:ln>
         </p:spPr>
         <p:txBody>
-          <a:bodyPr wrap="square" lIns="1778" tIns="1778" rIns="1778" bIns="1778" rtlCol="0" anchor="ctr"/>
+          <a:bodyPr wrap="square" lIns="127000" tIns="127000" rIns="127000" bIns="127000" rtlCol="0" anchor="ctr"/>
           <a:lstStyle/>
           <a:p>
             <a:pPr algn="l" indent="0" marL="0">
@@ -3300,7 +3300,7 @@
           </a:ln>
         </p:spPr>
         <p:txBody>
-          <a:bodyPr wrap="square" lIns="1778" tIns="1778" rIns="1778" bIns="1778" rtlCol="0" anchor="ctr"/>
+          <a:bodyPr wrap="square" lIns="127000" tIns="127000" rIns="127000" bIns="127000" rtlCol="0" anchor="ctr"/>
           <a:lstStyle/>
           <a:p>
             <a:pPr algn="l" indent="0" marL="0">
@@ -3361,7 +3361,7 @@
           </a:ln>
         </p:spPr>
         <p:txBody>
-          <a:bodyPr wrap="square" lIns="1778" tIns="1778" rIns="1778" bIns="1778" rtlCol="0" anchor="ctr"/>
+          <a:bodyPr wrap="square" lIns="127000" tIns="127000" rIns="127000" bIns="127000" rtlCol="0" anchor="ctr"/>
           <a:lstStyle/>
           <a:p>
             <a:pPr algn="l" indent="0" marL="0">
@@ -3422,7 +3422,7 @@
           </a:ln>
         </p:spPr>
         <p:txBody>
-          <a:bodyPr wrap="square" lIns="1778" tIns="1778" rIns="1778" bIns="1778" rtlCol="0" anchor="ctr"/>
+          <a:bodyPr wrap="square" lIns="127000" tIns="127000" rIns="127000" bIns="127000" rtlCol="0" anchor="ctr"/>
           <a:lstStyle/>
           <a:p>
             <a:pPr algn="ctr" indent="0" marL="0">
@@ -3535,7 +3535,7 @@
           </a:ln>
         </p:spPr>
         <p:txBody>
-          <a:bodyPr wrap="square" lIns="1778" tIns="1778" rIns="1778" bIns="1778" rtlCol="0" anchor="ctr"/>
+          <a:bodyPr wrap="square" lIns="127000" tIns="127000" rIns="127000" bIns="127000" rtlCol="0" anchor="ctr"/>
           <a:lstStyle/>
           <a:p>
             <a:pPr algn="l" indent="0" marL="0">
@@ -3596,7 +3596,7 @@
           </a:ln>
         </p:spPr>
         <p:txBody>
-          <a:bodyPr wrap="square" lIns="1778" tIns="1778" rIns="1778" bIns="1778" rtlCol="0" anchor="ctr"/>
+          <a:bodyPr wrap="square" lIns="127000" tIns="127000" rIns="127000" bIns="127000" rtlCol="0" anchor="ctr"/>
           <a:lstStyle/>
           <a:p>
             <a:pPr algn="l" indent="0" marL="0">
@@ -3657,7 +3657,7 @@
           </a:ln>
         </p:spPr>
         <p:txBody>
-          <a:bodyPr wrap="square" lIns="1778" tIns="1778" rIns="1778" bIns="1778" rtlCol="0" anchor="ctr"/>
+          <a:bodyPr wrap="square" lIns="127000" tIns="127000" rIns="127000" bIns="127000" rtlCol="0" anchor="ctr"/>
           <a:lstStyle/>
           <a:p>
             <a:pPr algn="l" indent="0" marL="0">
@@ -3718,7 +3718,7 @@
           </a:ln>
         </p:spPr>
         <p:txBody>
-          <a:bodyPr wrap="square" lIns="1778" tIns="1778" rIns="1778" bIns="1778" rtlCol="0" anchor="t"/>
+          <a:bodyPr wrap="square" lIns="127000" tIns="127000" rIns="127000" bIns="127000" rtlCol="0" anchor="t"/>
           <a:lstStyle/>
           <a:p>
             <a:pPr algn="l" indent="0" marL="0">
@@ -3951,7 +3951,7 @@
         <p:spPr>
           <a:xfrm>
             <a:off x="548640" y="777240"/>
-            <a:ext cx="11091672" cy="914400"/>
+            <a:ext cx="11091672" cy="1143000"/>
           </a:xfrm>
           <a:prstGeom prst="rect">
             <a:avLst/>
@@ -4007,7 +4007,7 @@
           </a:ln>
         </p:spPr>
         <p:txBody>
-          <a:bodyPr wrap="square" lIns="1778" tIns="1778" rIns="1778" bIns="1778" rtlCol="0" anchor="t"/>
+          <a:bodyPr wrap="square" lIns="127000" tIns="127000" rIns="127000" bIns="127000" rtlCol="0" anchor="t"/>
           <a:lstStyle/>
           <a:p>
             <a:pPr algn="l" indent="0" marL="0">
@@ -4071,7 +4071,7 @@
           </a:ln>
         </p:spPr>
         <p:txBody>
-          <a:bodyPr wrap="square" lIns="1778" tIns="1778" rIns="1778" bIns="1778" rtlCol="0" anchor="t"/>
+          <a:bodyPr wrap="square" lIns="127000" tIns="127000" rIns="127000" bIns="127000" rtlCol="0" anchor="t"/>
           <a:lstStyle/>
           <a:p>
             <a:pPr algn="l" indent="0" marL="0">
@@ -4135,7 +4135,7 @@
           </a:ln>
         </p:spPr>
         <p:txBody>
-          <a:bodyPr wrap="square" lIns="1778" tIns="1778" rIns="1778" bIns="1778" rtlCol="0" anchor="t"/>
+          <a:bodyPr wrap="square" lIns="127000" tIns="127000" rIns="127000" bIns="127000" rtlCol="0" anchor="t"/>
           <a:lstStyle/>
           <a:p>
             <a:pPr algn="l" indent="0" marL="0">
@@ -4274,7 +4274,7 @@
         <p:spPr>
           <a:xfrm>
             <a:off x="548640" y="777240"/>
-            <a:ext cx="11091672" cy="914400"/>
+            <a:ext cx="11091672" cy="1143000"/>
           </a:xfrm>
           <a:prstGeom prst="rect">
             <a:avLst/>
@@ -4330,7 +4330,7 @@
           </a:ln>
         </p:spPr>
         <p:txBody>
-          <a:bodyPr wrap="square" lIns="1778" tIns="1778" rIns="1778" bIns="1778" rtlCol="0" anchor="t"/>
+          <a:bodyPr wrap="square" lIns="127000" tIns="127000" rIns="127000" bIns="127000" rtlCol="0" anchor="t"/>
           <a:lstStyle/>
           <a:p>
             <a:pPr algn="l" indent="0" marL="0">
@@ -4394,7 +4394,7 @@
           </a:ln>
         </p:spPr>
         <p:txBody>
-          <a:bodyPr wrap="square" lIns="1778" tIns="1778" rIns="1778" bIns="1778" rtlCol="0" anchor="t"/>
+          <a:bodyPr wrap="square" lIns="127000" tIns="127000" rIns="127000" bIns="127000" rtlCol="0" anchor="t"/>
           <a:lstStyle/>
           <a:p>
             <a:pPr algn="l" indent="0" marL="0">
@@ -4458,7 +4458,7 @@
           </a:ln>
         </p:spPr>
         <p:txBody>
-          <a:bodyPr wrap="square" lIns="1778" tIns="1778" rIns="1778" bIns="1778" rtlCol="0" anchor="t"/>
+          <a:bodyPr wrap="square" lIns="127000" tIns="127000" rIns="127000" bIns="127000" rtlCol="0" anchor="t"/>
           <a:lstStyle/>
           <a:p>
             <a:pPr algn="l" indent="0" marL="0">
@@ -4597,7 +4597,7 @@
         <p:spPr>
           <a:xfrm>
             <a:off x="548640" y="777240"/>
-            <a:ext cx="11091672" cy="914400"/>
+            <a:ext cx="11091672" cy="1143000"/>
           </a:xfrm>
           <a:prstGeom prst="rect">
             <a:avLst/>
@@ -4653,7 +4653,7 @@
           </a:ln>
         </p:spPr>
         <p:txBody>
-          <a:bodyPr wrap="square" lIns="1778" tIns="1778" rIns="1778" bIns="1778" rtlCol="0" anchor="t"/>
+          <a:bodyPr wrap="square" lIns="127000" tIns="127000" rIns="127000" bIns="127000" rtlCol="0" anchor="t"/>
           <a:lstStyle/>
           <a:p>
             <a:pPr algn="l" indent="0" marL="0">
@@ -4717,7 +4717,7 @@
           </a:ln>
         </p:spPr>
         <p:txBody>
-          <a:bodyPr wrap="square" lIns="1778" tIns="1778" rIns="1778" bIns="1778" rtlCol="0" anchor="t"/>
+          <a:bodyPr wrap="square" lIns="127000" tIns="127000" rIns="127000" bIns="127000" rtlCol="0" anchor="t"/>
           <a:lstStyle/>
           <a:p>
             <a:pPr algn="l" indent="0" marL="0">
@@ -4781,7 +4781,7 @@
           </a:ln>
         </p:spPr>
         <p:txBody>
-          <a:bodyPr wrap="square" lIns="1778" tIns="1778" rIns="1778" bIns="1778" rtlCol="0" anchor="t"/>
+          <a:bodyPr wrap="square" lIns="127000" tIns="127000" rIns="127000" bIns="127000" rtlCol="0" anchor="t"/>
           <a:lstStyle/>
           <a:p>
             <a:pPr algn="l" indent="0" marL="0">
@@ -4920,7 +4920,7 @@
         <p:spPr>
           <a:xfrm>
             <a:off x="548640" y="777240"/>
-            <a:ext cx="11091672" cy="914400"/>
+            <a:ext cx="11091672" cy="1143000"/>
           </a:xfrm>
           <a:prstGeom prst="rect">
             <a:avLst/>
@@ -4976,7 +4976,7 @@
           </a:ln>
         </p:spPr>
         <p:txBody>
-          <a:bodyPr wrap="square" lIns="1778" tIns="1778" rIns="1778" bIns="1778" rtlCol="0" anchor="t"/>
+          <a:bodyPr wrap="square" lIns="127000" tIns="127000" rIns="127000" bIns="127000" rtlCol="0" anchor="t"/>
           <a:lstStyle/>
           <a:p>
             <a:pPr algn="l" indent="0" marL="0">
@@ -5112,7 +5112,7 @@
           </a:ln>
         </p:spPr>
         <p:txBody>
-          <a:bodyPr wrap="square" lIns="1778" tIns="1778" rIns="1778" bIns="1778" rtlCol="0" anchor="t"/>
+          <a:bodyPr wrap="square" lIns="127000" tIns="127000" rIns="127000" bIns="127000" rtlCol="0" anchor="t"/>
           <a:lstStyle/>
           <a:p>
             <a:pPr algn="l" indent="0" marL="0">
@@ -5176,7 +5176,7 @@
           </a:ln>
         </p:spPr>
         <p:txBody>
-          <a:bodyPr wrap="square" lIns="1778" tIns="1778" rIns="1778" bIns="1778" rtlCol="0" anchor="t"/>
+          <a:bodyPr wrap="square" lIns="127000" tIns="127000" rIns="127000" bIns="127000" rtlCol="0" anchor="t"/>
           <a:lstStyle/>
           <a:p>
             <a:pPr algn="l" indent="0" marL="0">
@@ -5240,7 +5240,7 @@
           </a:ln>
         </p:spPr>
         <p:txBody>
-          <a:bodyPr wrap="square" lIns="1778" tIns="1778" rIns="1778" bIns="1778" rtlCol="0" anchor="t"/>
+          <a:bodyPr wrap="square" lIns="127000" tIns="127000" rIns="127000" bIns="127000" rtlCol="0" anchor="t"/>
           <a:lstStyle/>
           <a:p>
             <a:pPr algn="l" indent="0" marL="0">
@@ -5304,7 +5304,7 @@
           </a:ln>
         </p:spPr>
         <p:txBody>
-          <a:bodyPr wrap="square" lIns="1778" tIns="1778" rIns="1778" bIns="1778" rtlCol="0" anchor="ctr"/>
+          <a:bodyPr wrap="square" lIns="127000" tIns="127000" rIns="127000" bIns="127000" rtlCol="0" anchor="ctr"/>
           <a:lstStyle/>
           <a:p>
             <a:pPr algn="l" indent="0" marL="0">
@@ -5440,7 +5440,7 @@
         <p:spPr>
           <a:xfrm>
             <a:off x="548640" y="777240"/>
-            <a:ext cx="11091672" cy="914400"/>
+            <a:ext cx="11091672" cy="1143000"/>
           </a:xfrm>
           <a:prstGeom prst="rect">
             <a:avLst/>
@@ -5496,7 +5496,7 @@
           </a:ln>
         </p:spPr>
         <p:txBody>
-          <a:bodyPr wrap="square" lIns="1778" tIns="1778" rIns="1778" bIns="1778" rtlCol="0" anchor="t"/>
+          <a:bodyPr wrap="square" lIns="127000" tIns="127000" rIns="127000" bIns="127000" rtlCol="0" anchor="t"/>
           <a:lstStyle/>
           <a:p>
             <a:pPr algn="l" indent="0" marL="0">
@@ -5566,7 +5566,7 @@
           </a:ln>
         </p:spPr>
         <p:txBody>
-          <a:bodyPr wrap="square" lIns="1778" tIns="1778" rIns="1778" bIns="1778" rtlCol="0" anchor="t"/>
+          <a:bodyPr wrap="square" lIns="127000" tIns="127000" rIns="127000" bIns="127000" rtlCol="0" anchor="t"/>
           <a:lstStyle/>
           <a:p>
             <a:pPr algn="l" indent="0" marL="0">
@@ -5647,7 +5647,7 @@
           </a:ln>
         </p:spPr>
         <p:txBody>
-          <a:bodyPr wrap="square" lIns="1778" tIns="1778" rIns="1778" bIns="1778" rtlCol="0" anchor="ctr"/>
+          <a:bodyPr wrap="square" lIns="127000" tIns="127000" rIns="127000" bIns="127000" rtlCol="0" anchor="ctr"/>
           <a:lstStyle/>
           <a:p>
             <a:pPr algn="l" indent="0" marL="0">
@@ -5783,7 +5783,7 @@
         <p:spPr>
           <a:xfrm>
             <a:off x="548640" y="777240"/>
-            <a:ext cx="11091672" cy="914400"/>
+            <a:ext cx="11091672" cy="1143000"/>
           </a:xfrm>
           <a:prstGeom prst="rect">
             <a:avLst/>
@@ -5839,7 +5839,7 @@
           </a:ln>
         </p:spPr>
         <p:txBody>
-          <a:bodyPr wrap="square" lIns="1778" tIns="1778" rIns="1778" bIns="1778" rtlCol="0" anchor="t"/>
+          <a:bodyPr wrap="square" lIns="127000" tIns="127000" rIns="127000" bIns="127000" rtlCol="0" anchor="t"/>
           <a:lstStyle/>
           <a:p>
             <a:pPr algn="l" indent="0" marL="0">
@@ -5926,7 +5926,7 @@
           </a:ln>
         </p:spPr>
         <p:txBody>
-          <a:bodyPr wrap="square" lIns="1778" tIns="1778" rIns="1778" bIns="1778" rtlCol="0" anchor="t"/>
+          <a:bodyPr wrap="square" lIns="127000" tIns="127000" rIns="127000" bIns="127000" rtlCol="0" anchor="t"/>
           <a:lstStyle/>
           <a:p>
             <a:pPr algn="l" indent="0" marL="0">
@@ -6013,7 +6013,7 @@
           </a:ln>
         </p:spPr>
         <p:txBody>
-          <a:bodyPr wrap="square" lIns="1778" tIns="1778" rIns="1778" bIns="1778" rtlCol="0" anchor="t"/>
+          <a:bodyPr wrap="square" lIns="127000" tIns="127000" rIns="127000" bIns="127000" rtlCol="0" anchor="t"/>
           <a:lstStyle/>
           <a:p>
             <a:pPr algn="l" indent="0" marL="0">
@@ -6178,7 +6178,7 @@
           </a:ln>
         </p:spPr>
         <p:txBody>
-          <a:bodyPr wrap="square" lIns="1778" tIns="1778" rIns="1778" bIns="1778" rtlCol="0" anchor="ctr"/>
+          <a:bodyPr wrap="square" lIns="127000" tIns="127000" rIns="127000" bIns="127000" rtlCol="0" anchor="ctr"/>
           <a:lstStyle/>
           <a:p>
             <a:pPr algn="l" indent="0" marL="0">
@@ -6328,7 +6328,7 @@
         <p:spPr>
           <a:xfrm>
             <a:off x="548640" y="777240"/>
-            <a:ext cx="11091672" cy="914400"/>
+            <a:ext cx="11091672" cy="1143000"/>
           </a:xfrm>
           <a:prstGeom prst="rect">
             <a:avLst/>
@@ -6384,7 +6384,7 @@
           </a:ln>
         </p:spPr>
         <p:txBody>
-          <a:bodyPr wrap="square" lIns="1778" tIns="1778" rIns="1778" bIns="1778" rtlCol="0" anchor="t"/>
+          <a:bodyPr wrap="square" lIns="127000" tIns="127000" rIns="127000" bIns="127000" rtlCol="0" anchor="t"/>
           <a:lstStyle/>
           <a:p>
             <a:pPr algn="l" indent="0" marL="0">
@@ -6516,7 +6516,7 @@
           </a:ln>
         </p:spPr>
         <p:txBody>
-          <a:bodyPr wrap="square" lIns="1778" tIns="1778" rIns="1778" bIns="1778" rtlCol="0" anchor="t"/>
+          <a:bodyPr wrap="square" lIns="127000" tIns="127000" rIns="127000" bIns="127000" rtlCol="0" anchor="t"/>
           <a:lstStyle/>
           <a:p>
             <a:pPr algn="l" indent="0" marL="0">
@@ -6597,7 +6597,7 @@
           </a:ln>
         </p:spPr>
         <p:txBody>
-          <a:bodyPr wrap="square" lIns="1778" tIns="1778" rIns="1778" bIns="1778" rtlCol="0" anchor="ctr"/>
+          <a:bodyPr wrap="square" lIns="127000" tIns="127000" rIns="127000" bIns="127000" rtlCol="0" anchor="ctr"/>
           <a:lstStyle/>
           <a:p>
             <a:pPr algn="ctr" indent="0" marL="0">
@@ -6719,7 +6719,7 @@
         <p:spPr>
           <a:xfrm>
             <a:off x="548640" y="777240"/>
-            <a:ext cx="11091672" cy="914400"/>
+            <a:ext cx="11091672" cy="1143000"/>
           </a:xfrm>
           <a:prstGeom prst="rect">
             <a:avLst/>
@@ -6775,7 +6775,7 @@
           </a:ln>
         </p:spPr>
         <p:txBody>
-          <a:bodyPr wrap="square" lIns="2286" tIns="2286" rIns="2286" bIns="2286" rtlCol="0" anchor="t"/>
+          <a:bodyPr wrap="square" lIns="165100" tIns="165100" rIns="165100" bIns="165100" rtlCol="0" anchor="t"/>
           <a:lstStyle/>
           <a:p>
             <a:pPr algn="l" indent="0" marL="0">
@@ -6907,7 +6907,7 @@
           </a:ln>
         </p:spPr>
         <p:txBody>
-          <a:bodyPr wrap="square" lIns="2286" tIns="2286" rIns="2286" bIns="2286" rtlCol="0" anchor="t"/>
+          <a:bodyPr wrap="square" lIns="165100" tIns="165100" rIns="165100" bIns="165100" rtlCol="0" anchor="t"/>
           <a:lstStyle/>
           <a:p>
             <a:pPr algn="l" indent="0" marL="0">
@@ -7039,7 +7039,7 @@
           </a:ln>
         </p:spPr>
         <p:txBody>
-          <a:bodyPr wrap="square" lIns="1778" tIns="1778" rIns="1778" bIns="1778" rtlCol="0" anchor="ctr"/>
+          <a:bodyPr wrap="square" lIns="127000" tIns="127000" rIns="127000" bIns="127000" rtlCol="0" anchor="ctr"/>
           <a:lstStyle/>
           <a:p>
             <a:pPr algn="ctr" indent="0" marL="0">
@@ -7161,7 +7161,7 @@
         <p:spPr>
           <a:xfrm>
             <a:off x="548640" y="777240"/>
-            <a:ext cx="11091672" cy="914400"/>
+            <a:ext cx="11091672" cy="1143000"/>
           </a:xfrm>
           <a:prstGeom prst="rect">
             <a:avLst/>
@@ -7217,7 +7217,7 @@
           </a:ln>
         </p:spPr>
         <p:txBody>
-          <a:bodyPr wrap="square" lIns="1778" tIns="1778" rIns="1778" bIns="1778" rtlCol="0" anchor="ctr"/>
+          <a:bodyPr wrap="square" lIns="127000" tIns="127000" rIns="127000" bIns="127000" rtlCol="0" anchor="ctr"/>
           <a:lstStyle/>
           <a:p>
             <a:pPr algn="l" indent="0" marL="0">
@@ -7292,7 +7292,7 @@
           </a:ln>
         </p:spPr>
         <p:txBody>
-          <a:bodyPr wrap="square" lIns="1778" tIns="1778" rIns="1778" bIns="1778" rtlCol="0" anchor="ctr"/>
+          <a:bodyPr wrap="square" lIns="127000" tIns="127000" rIns="127000" bIns="127000" rtlCol="0" anchor="ctr"/>
           <a:lstStyle/>
           <a:p>
             <a:pPr algn="l" indent="0" marL="0">
@@ -7367,7 +7367,7 @@
           </a:ln>
         </p:spPr>
         <p:txBody>
-          <a:bodyPr wrap="square" lIns="1778" tIns="1778" rIns="1778" bIns="1778" rtlCol="0" anchor="ctr"/>
+          <a:bodyPr wrap="square" lIns="127000" tIns="127000" rIns="127000" bIns="127000" rtlCol="0" anchor="ctr"/>
           <a:lstStyle/>
           <a:p>
             <a:pPr algn="l" indent="0" marL="0">
@@ -7442,7 +7442,7 @@
           </a:ln>
         </p:spPr>
         <p:txBody>
-          <a:bodyPr wrap="square" lIns="1778" tIns="1778" rIns="1778" bIns="1778" rtlCol="0" anchor="ctr"/>
+          <a:bodyPr wrap="square" lIns="127000" tIns="127000" rIns="127000" bIns="127000" rtlCol="0" anchor="ctr"/>
           <a:lstStyle/>
           <a:p>
             <a:pPr algn="ctr" indent="0" marL="0">
@@ -7564,7 +7564,7 @@
         <p:spPr>
           <a:xfrm>
             <a:off x="548640" y="777240"/>
-            <a:ext cx="11091672" cy="914400"/>
+            <a:ext cx="11091672" cy="1143000"/>
           </a:xfrm>
           <a:prstGeom prst="rect">
             <a:avLst/>
@@ -7620,7 +7620,7 @@
           </a:ln>
         </p:spPr>
         <p:txBody>
-          <a:bodyPr wrap="square" lIns="1778" tIns="1778" rIns="1778" bIns="1778" rtlCol="0" anchor="ctr"/>
+          <a:bodyPr wrap="square" lIns="127000" tIns="127000" rIns="127000" bIns="127000" rtlCol="0" anchor="ctr"/>
           <a:lstStyle/>
           <a:p>
             <a:pPr algn="l" indent="0" marL="0">
@@ -7667,7 +7667,7 @@
           </a:ln>
         </p:spPr>
         <p:txBody>
-          <a:bodyPr wrap="square" lIns="1778" tIns="1778" rIns="1778" bIns="1778" rtlCol="0" anchor="ctr"/>
+          <a:bodyPr wrap="square" lIns="127000" tIns="127000" rIns="127000" bIns="127000" rtlCol="0" anchor="ctr"/>
           <a:lstStyle/>
           <a:p>
             <a:pPr algn="l" indent="0" marL="0">
@@ -7714,7 +7714,7 @@
           </a:ln>
         </p:spPr>
         <p:txBody>
-          <a:bodyPr wrap="square" lIns="1778" tIns="1778" rIns="1778" bIns="1778" rtlCol="0" anchor="ctr"/>
+          <a:bodyPr wrap="square" lIns="127000" tIns="127000" rIns="127000" bIns="127000" rtlCol="0" anchor="ctr"/>
           <a:lstStyle/>
           <a:p>
             <a:pPr algn="l" indent="0" marL="0">
@@ -7761,7 +7761,7 @@
           </a:ln>
         </p:spPr>
         <p:txBody>
-          <a:bodyPr wrap="square" lIns="1778" tIns="1778" rIns="1778" bIns="1778" rtlCol="0" anchor="ctr"/>
+          <a:bodyPr wrap="square" lIns="127000" tIns="127000" rIns="127000" bIns="127000" rtlCol="0" anchor="ctr"/>
           <a:lstStyle/>
           <a:p>
             <a:pPr algn="l" indent="0" marL="0">
@@ -7808,7 +7808,7 @@
           </a:ln>
         </p:spPr>
         <p:txBody>
-          <a:bodyPr wrap="square" lIns="1778" tIns="1778" rIns="1778" bIns="1778" rtlCol="0" anchor="ctr"/>
+          <a:bodyPr wrap="square" lIns="127000" tIns="127000" rIns="127000" bIns="127000" rtlCol="0" anchor="ctr"/>
           <a:lstStyle/>
           <a:p>
             <a:pPr algn="l" indent="0" marL="0">
@@ -7855,7 +7855,7 @@
           </a:ln>
         </p:spPr>
         <p:txBody>
-          <a:bodyPr wrap="square" lIns="1778" tIns="1778" rIns="1778" bIns="1778" rtlCol="0" anchor="ctr"/>
+          <a:bodyPr wrap="square" lIns="127000" tIns="127000" rIns="127000" bIns="127000" rtlCol="0" anchor="ctr"/>
           <a:lstStyle/>
           <a:p>
             <a:pPr algn="l" indent="0" marL="0">
@@ -7902,7 +7902,7 @@
           </a:ln>
         </p:spPr>
         <p:txBody>
-          <a:bodyPr wrap="square" lIns="1778" tIns="1778" rIns="1778" bIns="1778" rtlCol="0" anchor="ctr"/>
+          <a:bodyPr wrap="square" lIns="127000" tIns="127000" rIns="127000" bIns="127000" rtlCol="0" anchor="ctr"/>
           <a:lstStyle/>
           <a:p>
             <a:pPr algn="l" indent="0" marL="0">
@@ -7949,7 +7949,7 @@
           </a:ln>
         </p:spPr>
         <p:txBody>
-          <a:bodyPr wrap="square" lIns="1778" tIns="1778" rIns="1778" bIns="1778" rtlCol="0" anchor="ctr"/>
+          <a:bodyPr wrap="square" lIns="127000" tIns="127000" rIns="127000" bIns="127000" rtlCol="0" anchor="ctr"/>
           <a:lstStyle/>
           <a:p>
             <a:pPr algn="l" indent="0" marL="0">
@@ -7996,7 +7996,7 @@
           </a:ln>
         </p:spPr>
         <p:txBody>
-          <a:bodyPr wrap="square" lIns="1778" tIns="1778" rIns="1778" bIns="1778" rtlCol="0" anchor="ctr"/>
+          <a:bodyPr wrap="square" lIns="127000" tIns="127000" rIns="127000" bIns="127000" rtlCol="0" anchor="ctr"/>
           <a:lstStyle/>
           <a:p>
             <a:pPr algn="l" indent="0" marL="0">
@@ -8132,7 +8132,7 @@
         <p:spPr>
           <a:xfrm>
             <a:off x="548640" y="777240"/>
-            <a:ext cx="11091672" cy="914400"/>
+            <a:ext cx="11091672" cy="1143000"/>
           </a:xfrm>
           <a:prstGeom prst="rect">
             <a:avLst/>
@@ -8170,12 +8170,12 @@
         </p:nvSpPr>
         <p:spPr>
           <a:xfrm>
-            <a:off x="548640" y="1828800"/>
-            <a:ext cx="5468112" cy="1097280"/>
+            <a:off x="548640" y="1874520"/>
+            <a:ext cx="5468112" cy="1371600"/>
           </a:xfrm>
           <a:prstGeom prst="roundRect">
             <a:avLst>
-              <a:gd name="adj" fmla="val 7500"/>
+              <a:gd name="adj" fmla="val 6000"/>
             </a:avLst>
           </a:prstGeom>
           <a:solidFill>
@@ -8188,7 +8188,7 @@
           </a:ln>
         </p:spPr>
         <p:txBody>
-          <a:bodyPr wrap="square" lIns="1778" tIns="1778" rIns="1778" bIns="1778" rtlCol="0" anchor="ctr"/>
+          <a:bodyPr wrap="square" lIns="127000" tIns="127000" rIns="127000" bIns="127000" rtlCol="0" anchor="ctr"/>
           <a:lstStyle/>
           <a:p>
             <a:pPr algn="l" indent="0" marL="0">
@@ -8203,8 +8203,11 @@
                 <a:ea typeface="Courier New" pitchFamily="34" charset="-122"/>
                 <a:cs typeface="Courier New" pitchFamily="34" charset="-120"/>
               </a:rPr>
-              <a:t>0.39   </a:t>
-            </a:r>
+              <a:t>0.39</a:t>
+            </a:r>
+            <a:endParaRPr lang="en-US" sz="1400" dirty="0"/>
+          </a:p>
+          <a:p>
             <a:pPr algn="l" indent="0" marL="0">
               <a:buNone/>
             </a:pPr>
@@ -8217,7 +8220,7 @@
                 <a:ea typeface="Arial" pitchFamily="34" charset="-122"/>
                 <a:cs typeface="Arial" pitchFamily="34" charset="-120"/>
               </a:rPr>
-              <a:t>rank correlation, 2014 scores vs what happened (0 = noise, 1 = perfect)</a:t>
+              <a:t>rank correlation vs what really happened (0 = noise, 1 = perfect)</a:t>
             </a:r>
             <a:endParaRPr lang="en-US" sz="1400" dirty="0"/>
           </a:p>
@@ -8231,12 +8234,12 @@
         </p:nvSpPr>
         <p:spPr>
           <a:xfrm>
-            <a:off x="6172200" y="1828800"/>
-            <a:ext cx="5468112" cy="1097280"/>
+            <a:off x="6172200" y="1874520"/>
+            <a:ext cx="5468112" cy="1371600"/>
           </a:xfrm>
           <a:prstGeom prst="roundRect">
             <a:avLst>
-              <a:gd name="adj" fmla="val 7500"/>
+              <a:gd name="adj" fmla="val 6000"/>
             </a:avLst>
           </a:prstGeom>
           <a:solidFill>
@@ -8249,7 +8252,7 @@
           </a:ln>
         </p:spPr>
         <p:txBody>
-          <a:bodyPr wrap="square" lIns="1778" tIns="1778" rIns="1778" bIns="1778" rtlCol="0" anchor="ctr"/>
+          <a:bodyPr wrap="square" lIns="127000" tIns="127000" rIns="127000" bIns="127000" rtlCol="0" anchor="ctr"/>
           <a:lstStyle/>
           <a:p>
             <a:pPr algn="l" indent="0" marL="0">
@@ -8264,8 +8267,11 @@
                 <a:ea typeface="Courier New" pitchFamily="34" charset="-122"/>
                 <a:cs typeface="Courier New" pitchFamily="34" charset="-120"/>
               </a:rPr>
-              <a:t>48%   </a:t>
-            </a:r>
+              <a:t>48%</a:t>
+            </a:r>
+            <a:endParaRPr lang="en-US" sz="1400" dirty="0"/>
+          </a:p>
+          <a:p>
             <a:pPr algn="l" indent="0" marL="0">
               <a:buNone/>
             </a:pPr>
@@ -8278,7 +8284,7 @@
                 <a:ea typeface="Arial" pitchFamily="34" charset="-122"/>
                 <a:cs typeface="Arial" pitchFamily="34" charset="-120"/>
               </a:rPr>
-              <a:t>of the careers that really declined were flagged — 33% by chance</a:t>
+              <a:t>of real decliners flagged — 33% by chance</a:t>
             </a:r>
             <a:endParaRPr lang="en-US" sz="1400" dirty="0"/>
           </a:p>
@@ -8292,12 +8298,12 @@
         </p:nvSpPr>
         <p:spPr>
           <a:xfrm>
-            <a:off x="548640" y="3063240"/>
-            <a:ext cx="5468112" cy="1097280"/>
+            <a:off x="548640" y="3337560"/>
+            <a:ext cx="5468112" cy="1371600"/>
           </a:xfrm>
           <a:prstGeom prst="roundRect">
             <a:avLst>
-              <a:gd name="adj" fmla="val 7500"/>
+              <a:gd name="adj" fmla="val 6000"/>
             </a:avLst>
           </a:prstGeom>
           <a:solidFill>
@@ -8310,7 +8316,7 @@
           </a:ln>
         </p:spPr>
         <p:txBody>
-          <a:bodyPr wrap="square" lIns="1778" tIns="1778" rIns="1778" bIns="1778" rtlCol="0" anchor="ctr"/>
+          <a:bodyPr wrap="square" lIns="127000" tIns="127000" rIns="127000" bIns="127000" rtlCol="0" anchor="ctr"/>
           <a:lstStyle/>
           <a:p>
             <a:pPr algn="l" indent="0" marL="0">
@@ -8325,8 +8331,11 @@
                 <a:ea typeface="Courier New" pitchFamily="34" charset="-122"/>
                 <a:cs typeface="Courier New" pitchFamily="34" charset="-120"/>
               </a:rPr>
-              <a:t>37 vs 46   </a:t>
-            </a:r>
+              <a:t>37 vs 46</a:t>
+            </a:r>
+            <a:endParaRPr lang="en-US" sz="1400" dirty="0"/>
+          </a:p>
+          <a:p>
             <a:pPr algn="l" indent="0" marL="0">
               <a:buNone/>
             </a:pPr>
@@ -8353,12 +8362,12 @@
         </p:nvSpPr>
         <p:spPr>
           <a:xfrm>
-            <a:off x="6172200" y="3063240"/>
-            <a:ext cx="5468112" cy="1097280"/>
+            <a:off x="6172200" y="3337560"/>
+            <a:ext cx="5468112" cy="1371600"/>
           </a:xfrm>
           <a:prstGeom prst="roundRect">
             <a:avLst>
-              <a:gd name="adj" fmla="val 7500"/>
+              <a:gd name="adj" fmla="val 6000"/>
             </a:avLst>
           </a:prstGeom>
           <a:solidFill>
@@ -8371,7 +8380,7 @@
           </a:ln>
         </p:spPr>
         <p:txBody>
-          <a:bodyPr wrap="square" lIns="1778" tIns="1778" rIns="1778" bIns="1778" rtlCol="0" anchor="ctr"/>
+          <a:bodyPr wrap="square" lIns="127000" tIns="127000" rIns="127000" bIns="127000" rtlCol="0" anchor="ctr"/>
           <a:lstStyle/>
           <a:p>
             <a:pPr algn="l" indent="0" marL="0">
@@ -8386,8 +8395,11 @@
                 <a:ea typeface="Courier New" pitchFamily="34" charset="-122"/>
                 <a:cs typeface="Courier New" pitchFamily="34" charset="-120"/>
               </a:rPr>
-              <a:t>~0   </a:t>
-            </a:r>
+              <a:t>~0</a:t>
+            </a:r>
+            <a:endParaRPr lang="en-US" sz="1400" dirty="0"/>
+          </a:p>
+          <a:p>
             <a:pPr algn="l" indent="0" marL="0">
               <a:buNone/>
             </a:pPr>
@@ -8400,7 +8412,7 @@
                 <a:ea typeface="Arial" pitchFamily="34" charset="-122"/>
                 <a:cs typeface="Arial" pitchFamily="34" charset="-120"/>
               </a:rPr>
-              <a:t>AI exposure’s signal that decade — expected, no LLMs existed yet</a:t>
+              <a:t>AI exposure’s signal — expected: no LLMs yet</a:t>
             </a:r>
             <a:endParaRPr lang="en-US" sz="1400" dirty="0"/>
           </a:p>
@@ -8414,12 +8426,12 @@
         </p:nvSpPr>
         <p:spPr>
           <a:xfrm>
-            <a:off x="548640" y="4434840"/>
-            <a:ext cx="11091672" cy="1691640"/>
+            <a:off x="548640" y="4846320"/>
+            <a:ext cx="11091672" cy="1828800"/>
           </a:xfrm>
           <a:prstGeom prst="roundRect">
             <a:avLst>
-              <a:gd name="adj" fmla="val 4865"/>
+              <a:gd name="adj" fmla="val 4500"/>
             </a:avLst>
           </a:prstGeom>
           <a:solidFill>
@@ -8432,7 +8444,7 @@
           </a:ln>
         </p:spPr>
         <p:txBody>
-          <a:bodyPr wrap="square" lIns="1778" tIns="1778" rIns="1778" bIns="1778" rtlCol="0" anchor="t"/>
+          <a:bodyPr wrap="square" lIns="127000" tIns="127000" rIns="127000" bIns="127000" rtlCol="0" anchor="t"/>
           <a:lstStyle/>
           <a:p>
             <a:pPr algn="l" indent="0" marL="0">

</xml_diff>